<commit_message>
Configure PDF report with short abstract and search route, and PowerPoint slides with light theme and logical steps
</commit_message>
<xml_diff>
--- a/AeroQuest_Presentation_Final.pptx
+++ b/AeroQuest_Presentation_Final.pptx
@@ -3917,7 +3917,7 @@
               </a:defRPr>
             </a:pPr>
             <a:r>
-              <a:t>13. Chart.js Comparison Trends</a:t>
+              <a:t>13. Coding - Logical Steps</a:t>
             </a:r>
           </a:p>
         </p:txBody>
@@ -3956,55 +3956,71 @@
               </a:defRPr>
             </a:pPr>
             <a:r>
-              <a:t>•  Allows users to load and compare two cities side-by-side.</a:t>
-            </a:r>
-          </a:p>
-          <a:p>
-            <a:pPr>
-              <a:spcAft>
-                <a:spcPts val="1600"/>
-              </a:spcAft>
-              <a:defRPr sz="2000">
-                <a:solidFill>
-                  <a:srgbClr val="111827"/>
-                </a:solidFill>
-                <a:latin typeface="Inter"/>
-              </a:defRPr>
-            </a:pPr>
-            <a:r>
-              <a:t>•  Interactive line charts render 24-hour pollutant and AQI trends.</a:t>
-            </a:r>
-          </a:p>
-          <a:p>
-            <a:pPr>
-              <a:spcAft>
-                <a:spcPts val="1600"/>
-              </a:spcAft>
-              <a:defRPr sz="2000">
-                <a:solidFill>
-                  <a:srgbClr val="111827"/>
-                </a:solidFill>
-                <a:latin typeface="Inter"/>
-              </a:defRPr>
-            </a:pPr>
-            <a:r>
-              <a:t>•  Helps users analyze temporal variations (day vs night pollution patterns).</a:t>
-            </a:r>
-          </a:p>
-          <a:p>
-            <a:pPr>
-              <a:spcAft>
-                <a:spcPts val="1600"/>
-              </a:spcAft>
-              <a:defRPr sz="2000">
-                <a:solidFill>
-                  <a:srgbClr val="111827"/>
-                </a:solidFill>
-                <a:latin typeface="Inter"/>
-              </a:defRPr>
-            </a:pPr>
-            <a:r>
-              <a:t>•  Chart configurations scale dynamically based on selected units.</a:t>
+              <a:t>•  1. Read the city name searched by the user.</a:t>
+            </a:r>
+          </a:p>
+          <a:p>
+            <a:pPr>
+              <a:spcAft>
+                <a:spcPts val="1600"/>
+              </a:spcAft>
+              <a:defRPr sz="2000">
+                <a:solidFill>
+                  <a:srgbClr val="111827"/>
+                </a:solidFill>
+                <a:latin typeface="Inter"/>
+              </a:defRPr>
+            </a:pPr>
+            <a:r>
+              <a:t>•  2. Call Geocoding API to get the city coordinates.</a:t>
+            </a:r>
+          </a:p>
+          <a:p>
+            <a:pPr>
+              <a:spcAft>
+                <a:spcPts val="1600"/>
+              </a:spcAft>
+              <a:defRPr sz="2000">
+                <a:solidFill>
+                  <a:srgbClr val="111827"/>
+                </a:solidFill>
+                <a:latin typeface="Inter"/>
+              </a:defRPr>
+            </a:pPr>
+            <a:r>
+              <a:t>•  3. Fetch weather and air quality values using coordinates.</a:t>
+            </a:r>
+          </a:p>
+          <a:p>
+            <a:pPr>
+              <a:spcAft>
+                <a:spcPts val="1600"/>
+              </a:spcAft>
+              <a:defRPr sz="2000">
+                <a:solidFill>
+                  <a:srgbClr val="111827"/>
+                </a:solidFill>
+                <a:latin typeface="Inter"/>
+              </a:defRPr>
+            </a:pPr>
+            <a:r>
+              <a:t>•  4. Calculate safety guidelines based on WHO pollutant limits.</a:t>
+            </a:r>
+          </a:p>
+          <a:p>
+            <a:pPr>
+              <a:spcAft>
+                <a:spcPts val="1600"/>
+              </a:spcAft>
+              <a:defRPr sz="2000">
+                <a:solidFill>
+                  <a:srgbClr val="111827"/>
+                </a:solidFill>
+                <a:latin typeface="Inter"/>
+              </a:defRPr>
+            </a:pPr>
+            <a:r>
+              <a:t>•  5. Save bookmarked cities to SQLite and sort on the leaderboard.</a:t>
             </a:r>
           </a:p>
         </p:txBody>

</xml_diff>

<commit_message>
Configure AeroQuest PowerPoint presentation to match the layout of Medicine Reminder System
</commit_message>
<xml_diff>
--- a/AeroQuest_Presentation_Final.pptx
+++ b/AeroQuest_Presentation_Final.pptx
@@ -22,6 +22,7 @@
     <p:sldId id="270" r:id="rId21"/>
     <p:sldId id="271" r:id="rId22"/>
     <p:sldId id="272" r:id="rId23"/>
+    <p:sldId id="273" r:id="rId24"/>
   </p:sldIdLst>
   <p:sldSz cx="12191695" cy="6858000" type="screen4x3"/>
   <p:notesSz cx="6858000" cy="9144000"/>
@@ -3121,7 +3122,7 @@
         <p:spPr>
           <a:xfrm>
             <a:off x="914400" y="457200"/>
-            <a:ext cx="10360152" cy="548640"/>
+            <a:ext cx="10360152" cy="5943600"/>
           </a:xfrm>
           <a:prstGeom prst="rect">
             <a:avLst/>
@@ -3129,73 +3130,53 @@
           <a:noFill/>
         </p:spPr>
         <p:txBody>
-          <a:bodyPr wrap="none">
-            <a:spAutoFit/>
-          </a:bodyPr>
-          <a:lstStyle/>
-          <a:p>
-            <a:pPr algn="ctr">
-              <a:defRPr sz="1400" b="1">
-                <a:solidFill>
-                  <a:srgbClr val="6B7280"/>
-                </a:solidFill>
-                <a:latin typeface="Outfit"/>
-              </a:defRPr>
-            </a:pPr>
-            <a:r>
-              <a:t>DEPARTMENT OF COMPUTER SCIENCE AND ENGINEERING</a:t>
-            </a:r>
-          </a:p>
-        </p:txBody>
-      </p:sp>
-      <p:sp>
-        <p:nvSpPr>
-          <p:cNvPr id="3" name="TextBox 2"/>
-          <p:cNvSpPr txBox="1"/>
-          <p:nvPr/>
-        </p:nvSpPr>
-        <p:spPr>
-          <a:xfrm>
-            <a:off x="914400" y="1371600"/>
-            <a:ext cx="10360152" cy="4114800"/>
-          </a:xfrm>
-          <a:prstGeom prst="rect">
-            <a:avLst/>
-          </a:prstGeom>
-          <a:noFill/>
-        </p:spPr>
-        <p:txBody>
           <a:bodyPr wrap="square">
             <a:spAutoFit/>
           </a:bodyPr>
           <a:lstStyle/>
           <a:p>
             <a:pPr algn="ctr">
-              <a:defRPr sz="6400" b="1">
-                <a:solidFill>
-                  <a:srgbClr val="1A56DB"/>
+              <a:defRPr sz="2000" b="1">
+                <a:solidFill>
+                  <a:srgbClr val="111827"/>
                 </a:solidFill>
                 <a:latin typeface="Outfit"/>
               </a:defRPr>
             </a:pPr>
             <a:r>
-              <a:t>AeroQuest</a:t>
+              <a:t>MINI PROJECT REPORT</a:t>
             </a:r>
           </a:p>
           <a:p>
             <a:pPr algn="ctr">
               <a:spcBef>
-                <a:spcPts val="1500"/>
+                <a:spcPts val="2000"/>
               </a:spcBef>
-              <a:defRPr sz="1800">
-                <a:solidFill>
-                  <a:srgbClr val="111827"/>
+              <a:defRPr sz="3600" b="1">
+                <a:solidFill>
+                  <a:srgbClr val="1A56DB"/>
+                </a:solidFill>
+                <a:latin typeface="Outfit"/>
+              </a:defRPr>
+            </a:pPr>
+            <a:r>
+              <a:t>AEROQUEST: GLOBAL AIR QUALITY &amp; WEATHER ANALYTICS HUB</a:t>
+            </a:r>
+          </a:p>
+          <a:p>
+            <a:pPr algn="ctr">
+              <a:spcBef>
+                <a:spcPts val="1000"/>
+              </a:spcBef>
+              <a:defRPr sz="1600" i="1">
+                <a:solidFill>
+                  <a:srgbClr val="6B7280"/>
                 </a:solidFill>
                 <a:latin typeface="Inter"/>
               </a:defRPr>
             </a:pPr>
             <a:r>
-              <a:t>Advanced PYTHON &amp; Flask Web Application for Global Air Quality &amp; Weather Analytics</a:t>
+              <a:t>A Python-Based Application for Real-Time Atmospheric Monitoring</a:t>
             </a:r>
           </a:p>
           <a:p>
@@ -3205,6 +3186,35 @@
               </a:spcBef>
               <a:defRPr sz="1300">
                 <a:solidFill>
+                  <a:srgbClr val="111827"/>
+                </a:solidFill>
+                <a:latin typeface="Inter"/>
+              </a:defRPr>
+            </a:pPr>
+            <a:r>
+              <a:t>Submitted in partial fulfilment of the requirements for</a:t>
+            </a:r>
+          </a:p>
+          <a:p>
+            <a:pPr algn="ctr">
+              <a:defRPr sz="1300" b="1">
+                <a:solidFill>
+                  <a:srgbClr val="111827"/>
+                </a:solidFill>
+                <a:latin typeface="Inter"/>
+              </a:defRPr>
+            </a:pPr>
+            <a:r>
+              <a:t>Course: 25BEphy104 (Python Programming)</a:t>
+            </a:r>
+          </a:p>
+          <a:p>
+            <a:pPr algn="ctr">
+              <a:spcBef>
+                <a:spcPts val="2000"/>
+              </a:spcBef>
+              <a:defRPr sz="1200">
+                <a:solidFill>
                   <a:srgbClr val="6B7280"/>
                 </a:solidFill>
                 <a:latin typeface="Inter"/>
@@ -3227,7 +3237,7 @@
               </a:defRPr>
             </a:pPr>
             <a:r>
-              <a:t>SHIVARAJ (25SUUBECS1323) | SHIVAKUMAR KH (25SUUBECS1319)</a:t>
+              <a:t>SHIVARAJ - 25SUUBECS1323  |  SHIVAKUMAR KH - 25SUUBECS1319</a:t>
             </a:r>
           </a:p>
           <a:p>
@@ -3243,7 +3253,7 @@
               </a:defRPr>
             </a:pPr>
             <a:r>
-              <a:t>SHREYAS AG (25SUUBECS1351) | SHREYAS HS (25SUUBECS1354)</a:t>
+              <a:t>SHREYAS AG - 25SUUBECS1351  |  SHREYAS HS - 25SUUBECS1354</a:t>
             </a:r>
           </a:p>
           <a:p>
@@ -3259,7 +3269,36 @@
               </a:defRPr>
             </a:pPr>
             <a:r>
-              <a:t>SHREYAS SUVIGYA (25SUUBECS1361)</a:t>
+              <a:t>SHREYAS SUVIGYA - 25SUUBECS1361</a:t>
+            </a:r>
+          </a:p>
+          <a:p>
+            <a:pPr algn="ctr">
+              <a:spcBef>
+                <a:spcPts val="2000"/>
+              </a:spcBef>
+              <a:defRPr sz="1200">
+                <a:solidFill>
+                  <a:srgbClr val="111827"/>
+                </a:solidFill>
+                <a:latin typeface="Inter"/>
+              </a:defRPr>
+            </a:pPr>
+            <a:r>
+              <a:t>Department of Computer Science and Engineering</a:t>
+            </a:r>
+          </a:p>
+          <a:p>
+            <a:pPr algn="ctr">
+              <a:defRPr sz="1200">
+                <a:solidFill>
+                  <a:srgbClr val="111827"/>
+                </a:solidFill>
+                <a:latin typeface="Inter"/>
+              </a:defRPr>
+            </a:pPr>
+            <a:r>
+              <a:t>2026</a:t>
             </a:r>
           </a:p>
         </p:txBody>
@@ -3321,7 +3360,7 @@
               </a:defRPr>
             </a:pPr>
             <a:r>
-              <a:t>9. WHO Exceedance Alerts</a:t>
+              <a:t>2.2 ALGORITHM (STEP-WISE LOGIC)</a:t>
             </a:r>
           </a:p>
         </p:txBody>
@@ -3360,7 +3399,7 @@
               </a:defRPr>
             </a:pPr>
             <a:r>
-              <a:t>•  Alert Processor: Compares pollutant concentrations against daily WHO safety limits.</a:t>
+              <a:t>•  Step 1: Accept search query, log in database, and get coordinates from Geocoding API.</a:t>
             </a:r>
           </a:p>
           <a:p>
@@ -3376,7 +3415,7 @@
               </a:defRPr>
             </a:pPr>
             <a:r>
-              <a:t>•  Unit Conversion: Scales Carbon Monoxide (CO) from micrograms to milligrams (divided by 1000).</a:t>
+              <a:t>•  Step 2: Query Open-Meteo forecasts and WAQI live ground-stations using coordinates.</a:t>
             </a:r>
           </a:p>
           <a:p>
@@ -3392,7 +3431,7 @@
               </a:defRPr>
             </a:pPr>
             <a:r>
-              <a:t>•  Alert Multiplier: Multiplier = (Current Concentration) / (WHO Safety Limit).</a:t>
+              <a:t>•  Step 3: Verify distance between queried coordinates and ground-station coordinates to prevent hijack redirects.</a:t>
             </a:r>
           </a:p>
           <a:p>
@@ -3408,7 +3447,23 @@
               </a:defRPr>
             </a:pPr>
             <a:r>
-              <a:t>•  Dashboard alerts highlight exceedance ratios (e.g. 'PM2.5 is 2.4x above WHO limits').</a:t>
+              <a:t>•  Step 4: Scale pollutants, check against WHO safe guidelines, and calculate weather stagnation warnings.</a:t>
+            </a:r>
+          </a:p>
+          <a:p>
+            <a:pPr>
+              <a:spcAft>
+                <a:spcPts val="1600"/>
+              </a:spcAft>
+              <a:defRPr sz="2000">
+                <a:solidFill>
+                  <a:srgbClr val="111827"/>
+                </a:solidFill>
+                <a:latin typeface="Inter"/>
+              </a:defRPr>
+            </a:pPr>
+            <a:r>
+              <a:t>•  Step 5: Load favorites database, sort cleanest cities ascending, and render leaderboard.</a:t>
             </a:r>
           </a:p>
         </p:txBody>
@@ -3470,7 +3525,7 @@
               </a:defRPr>
             </a:pPr>
             <a:r>
-              <a:t>10. Stagnation &amp; Dispersion Engine</a:t>
+              <a:t>2.3 CODE WITH COMMENTS (PART 1: FLASK APP SETUP)</a:t>
             </a:r>
           </a:p>
         </p:txBody>
@@ -3483,8 +3538,8 @@
         </p:nvSpPr>
         <p:spPr>
           <a:xfrm>
-            <a:off x="914400" y="1828800"/>
-            <a:ext cx="10360152" cy="4114800"/>
+            <a:off x="1371600" y="1828800"/>
+            <a:ext cx="9445752" cy="4114800"/>
           </a:xfrm>
           <a:prstGeom prst="rect">
             <a:avLst/>
@@ -3499,65 +3554,155 @@
           <a:p>
             <a:pPr>
               <a:spcAft>
-                <a:spcPts val="1600"/>
-              </a:spcAft>
-              <a:defRPr sz="2000">
-                <a:solidFill>
-                  <a:srgbClr val="111827"/>
-                </a:solidFill>
-                <a:latin typeface="Inter"/>
-              </a:defRPr>
-            </a:pPr>
-            <a:r>
-              <a:t>•  Stagnation warning: Triggered when wind speed &lt; 10 km/h and relative humidity &gt; 80%.</a:t>
-            </a:r>
-          </a:p>
-          <a:p>
-            <a:pPr>
-              <a:spcAft>
-                <a:spcPts val="1600"/>
-              </a:spcAft>
-              <a:defRPr sz="2000">
-                <a:solidFill>
-                  <a:srgbClr val="111827"/>
-                </a:solidFill>
-                <a:latin typeface="Inter"/>
-              </a:defRPr>
-            </a:pPr>
-            <a:r>
-              <a:t>•  Warns users that low wind speeds and damp conditions trap particulate matter near the ground.</a:t>
-            </a:r>
-          </a:p>
-          <a:p>
-            <a:pPr>
-              <a:spcAft>
-                <a:spcPts val="1600"/>
-              </a:spcAft>
-              <a:defRPr sz="2000">
-                <a:solidFill>
-                  <a:srgbClr val="111827"/>
-                </a:solidFill>
-                <a:latin typeface="Inter"/>
-              </a:defRPr>
-            </a:pPr>
-            <a:r>
-              <a:t>•  Dispersion indicator: Explains how high winds (&gt; 15 km/h) clean the local air volume.</a:t>
-            </a:r>
-          </a:p>
-          <a:p>
-            <a:pPr>
-              <a:spcAft>
-                <a:spcPts val="1600"/>
-              </a:spcAft>
-              <a:defRPr sz="2000">
-                <a:solidFill>
-                  <a:srgbClr val="111827"/>
-                </a:solidFill>
-                <a:latin typeface="Inter"/>
-              </a:defRPr>
-            </a:pPr>
-            <a:r>
-              <a:t>•  Helps users decide when to ventilate their homes or run air purifiers.</a:t>
+                <a:spcPts val="100"/>
+              </a:spcAft>
+              <a:defRPr sz="1300">
+                <a:solidFill>
+                  <a:srgbClr val="111827"/>
+                </a:solidFill>
+                <a:latin typeface="Courier New"/>
+              </a:defRPr>
+            </a:pPr>
+            <a:r>
+              <a:t>from flask import Flask, render_template, request, jsonify</a:t>
+            </a:r>
+          </a:p>
+          <a:p>
+            <a:pPr>
+              <a:spcAft>
+                <a:spcPts val="100"/>
+              </a:spcAft>
+              <a:defRPr sz="1300">
+                <a:solidFill>
+                  <a:srgbClr val="111827"/>
+                </a:solidFill>
+                <a:latin typeface="Courier New"/>
+              </a:defRPr>
+            </a:pPr>
+            <a:r>
+              <a:t>import requests</a:t>
+            </a:r>
+          </a:p>
+          <a:p>
+            <a:pPr>
+              <a:spcAft>
+                <a:spcPts val="100"/>
+              </a:spcAft>
+              <a:defRPr sz="1300">
+                <a:solidFill>
+                  <a:srgbClr val="111827"/>
+                </a:solidFill>
+                <a:latin typeface="Courier New"/>
+              </a:defRPr>
+            </a:pPr>
+            <a:r>
+              <a:t>import database</a:t>
+            </a:r>
+          </a:p>
+          <a:p>
+            <a:pPr>
+              <a:spcAft>
+                <a:spcPts val="100"/>
+              </a:spcAft>
+              <a:defRPr sz="1300">
+                <a:solidFill>
+                  <a:srgbClr val="111827"/>
+                </a:solidFill>
+                <a:latin typeface="Courier New"/>
+              </a:defRPr>
+            </a:pPr>
+          </a:p>
+          <a:p>
+            <a:pPr>
+              <a:spcAft>
+                <a:spcPts val="100"/>
+              </a:spcAft>
+              <a:defRPr sz="1300">
+                <a:solidFill>
+                  <a:srgbClr val="111827"/>
+                </a:solidFill>
+                <a:latin typeface="Courier New"/>
+              </a:defRPr>
+            </a:pPr>
+            <a:r>
+              <a:t>app = Flask(__name__)</a:t>
+            </a:r>
+          </a:p>
+          <a:p>
+            <a:pPr>
+              <a:spcAft>
+                <a:spcPts val="100"/>
+              </a:spcAft>
+              <a:defRPr sz="1300">
+                <a:solidFill>
+                  <a:srgbClr val="111827"/>
+                </a:solidFill>
+                <a:latin typeface="Courier New"/>
+              </a:defRPr>
+            </a:pPr>
+            <a:r>
+              <a:t>database.init_db()  # Initialize database tables</a:t>
+            </a:r>
+          </a:p>
+          <a:p>
+            <a:pPr>
+              <a:spcAft>
+                <a:spcPts val="100"/>
+              </a:spcAft>
+              <a:defRPr sz="1300">
+                <a:solidFill>
+                  <a:srgbClr val="111827"/>
+                </a:solidFill>
+                <a:latin typeface="Courier New"/>
+              </a:defRPr>
+            </a:pPr>
+          </a:p>
+          <a:p>
+            <a:pPr>
+              <a:spcAft>
+                <a:spcPts val="100"/>
+              </a:spcAft>
+              <a:defRPr sz="1300">
+                <a:solidFill>
+                  <a:srgbClr val="111827"/>
+                </a:solidFill>
+                <a:latin typeface="Courier New"/>
+              </a:defRPr>
+            </a:pPr>
+            <a:r>
+              <a:t>@app.route('/')</a:t>
+            </a:r>
+          </a:p>
+          <a:p>
+            <a:pPr>
+              <a:spcAft>
+                <a:spcPts val="100"/>
+              </a:spcAft>
+              <a:defRPr sz="1300">
+                <a:solidFill>
+                  <a:srgbClr val="111827"/>
+                </a:solidFill>
+                <a:latin typeface="Courier New"/>
+              </a:defRPr>
+            </a:pPr>
+            <a:r>
+              <a:t>def index():</a:t>
+            </a:r>
+          </a:p>
+          <a:p>
+            <a:pPr>
+              <a:spcAft>
+                <a:spcPts val="100"/>
+              </a:spcAft>
+              <a:defRPr sz="1300">
+                <a:solidFill>
+                  <a:srgbClr val="111827"/>
+                </a:solidFill>
+                <a:latin typeface="Courier New"/>
+              </a:defRPr>
+            </a:pPr>
+            <a:r>
+              <a:t>    return render_template('index.html')  # Serves main UI page</a:t>
             </a:r>
           </a:p>
         </p:txBody>
@@ -3619,7 +3764,7 @@
               </a:defRPr>
             </a:pPr>
             <a:r>
-              <a:t>11. Cleanest Cities Leaderboard</a:t>
+              <a:t>2.3 CODE WITH COMMENTS (PART 2: WEATHER &amp; AQI API)</a:t>
             </a:r>
           </a:p>
         </p:txBody>
@@ -3632,8 +3777,8 @@
         </p:nvSpPr>
         <p:spPr>
           <a:xfrm>
-            <a:off x="914400" y="1828800"/>
-            <a:ext cx="10360152" cy="4114800"/>
+            <a:off x="1371600" y="1828800"/>
+            <a:ext cx="9445752" cy="4114800"/>
           </a:xfrm>
           <a:prstGeom prst="rect">
             <a:avLst/>
@@ -3648,65 +3793,161 @@
           <a:p>
             <a:pPr>
               <a:spcAft>
-                <a:spcPts val="1600"/>
-              </a:spcAft>
-              <a:defRPr sz="2000">
-                <a:solidFill>
-                  <a:srgbClr val="111827"/>
-                </a:solidFill>
-                <a:latin typeface="Inter"/>
-              </a:defRPr>
-            </a:pPr>
-            <a:r>
-              <a:t>•  Retrieves favorites and queries live ground-station values.</a:t>
-            </a:r>
-          </a:p>
-          <a:p>
-            <a:pPr>
-              <a:spcAft>
-                <a:spcPts val="1600"/>
-              </a:spcAft>
-              <a:defRPr sz="2000">
-                <a:solidFill>
-                  <a:srgbClr val="111827"/>
-                </a:solidFill>
-                <a:latin typeface="Inter"/>
-              </a:defRPr>
-            </a:pPr>
-            <a:r>
-              <a:t>•  Dynamic Sorting: Arranges bookmarked cities ascending based on AQI.</a:t>
-            </a:r>
-          </a:p>
-          <a:p>
-            <a:pPr>
-              <a:spcAft>
-                <a:spcPts val="1600"/>
-              </a:spcAft>
-              <a:defRPr sz="2000">
-                <a:solidFill>
-                  <a:srgbClr val="111827"/>
-                </a:solidFill>
-                <a:latin typeface="Inter"/>
-              </a:defRPr>
-            </a:pPr>
-            <a:r>
-              <a:t>•  Highlights the cleanest favorited cities at the top of the leaderboard.</a:t>
-            </a:r>
-          </a:p>
-          <a:p>
-            <a:pPr>
-              <a:spcAft>
-                <a:spcPts val="1600"/>
-              </a:spcAft>
-              <a:defRPr sz="2000">
-                <a:solidFill>
-                  <a:srgbClr val="111827"/>
-                </a:solidFill>
-                <a:latin typeface="Inter"/>
-              </a:defRPr>
-            </a:pPr>
-            <a:r>
-              <a:t>•  Interactive UI uses color-coded badges matching the AQI severity scale.</a:t>
+                <a:spcPts val="100"/>
+              </a:spcAft>
+              <a:defRPr sz="1300">
+                <a:solidFill>
+                  <a:srgbClr val="111827"/>
+                </a:solidFill>
+                <a:latin typeface="Courier New"/>
+              </a:defRPr>
+            </a:pPr>
+            <a:r>
+              <a:t>@app.route('/api/air-quality')</a:t>
+            </a:r>
+          </a:p>
+          <a:p>
+            <a:pPr>
+              <a:spcAft>
+                <a:spcPts val="100"/>
+              </a:spcAft>
+              <a:defRPr sz="1300">
+                <a:solidFill>
+                  <a:srgbClr val="111827"/>
+                </a:solidFill>
+                <a:latin typeface="Courier New"/>
+              </a:defRPr>
+            </a:pPr>
+            <a:r>
+              <a:t>def get_air_quality():</a:t>
+            </a:r>
+          </a:p>
+          <a:p>
+            <a:pPr>
+              <a:spcAft>
+                <a:spcPts val="100"/>
+              </a:spcAft>
+              <a:defRPr sz="1300">
+                <a:solidFill>
+                  <a:srgbClr val="111827"/>
+                </a:solidFill>
+                <a:latin typeface="Courier New"/>
+              </a:defRPr>
+            </a:pPr>
+            <a:r>
+              <a:t>    lat = request.args.get('latitude')</a:t>
+            </a:r>
+          </a:p>
+          <a:p>
+            <a:pPr>
+              <a:spcAft>
+                <a:spcPts val="100"/>
+              </a:spcAft>
+              <a:defRPr sz="1300">
+                <a:solidFill>
+                  <a:srgbClr val="111827"/>
+                </a:solidFill>
+                <a:latin typeface="Courier New"/>
+              </a:defRPr>
+            </a:pPr>
+            <a:r>
+              <a:t>    lon = request.args.get('longitude')</a:t>
+            </a:r>
+          </a:p>
+          <a:p>
+            <a:pPr>
+              <a:spcAft>
+                <a:spcPts val="100"/>
+              </a:spcAft>
+              <a:defRPr sz="1300">
+                <a:solidFill>
+                  <a:srgbClr val="111827"/>
+                </a:solidFill>
+                <a:latin typeface="Courier New"/>
+              </a:defRPr>
+            </a:pPr>
+            <a:r>
+              <a:t>    # Fetch Open-Meteo Air Quality forecasts</a:t>
+            </a:r>
+          </a:p>
+          <a:p>
+            <a:pPr>
+              <a:spcAft>
+                <a:spcPts val="100"/>
+              </a:spcAft>
+              <a:defRPr sz="1300">
+                <a:solidFill>
+                  <a:srgbClr val="111827"/>
+                </a:solidFill>
+                <a:latin typeface="Courier New"/>
+              </a:defRPr>
+            </a:pPr>
+            <a:r>
+              <a:t>    aqi_url = f"https://air-quality-api.open-meteo.com/v1/air-quality?latitude={lat}&amp;longitude={lon}&amp;current=us_aqi,pm2_5,pm10,carbon_monoxide,nitrogen_dioxide"</a:t>
+            </a:r>
+          </a:p>
+          <a:p>
+            <a:pPr>
+              <a:spcAft>
+                <a:spcPts val="100"/>
+              </a:spcAft>
+              <a:defRPr sz="1300">
+                <a:solidFill>
+                  <a:srgbClr val="111827"/>
+                </a:solidFill>
+                <a:latin typeface="Courier New"/>
+              </a:defRPr>
+            </a:pPr>
+            <a:r>
+              <a:t>    aqi_data = requests.get(aqi_url).json()</a:t>
+            </a:r>
+          </a:p>
+          <a:p>
+            <a:pPr>
+              <a:spcAft>
+                <a:spcPts val="100"/>
+              </a:spcAft>
+              <a:defRPr sz="1300">
+                <a:solidFill>
+                  <a:srgbClr val="111827"/>
+                </a:solidFill>
+                <a:latin typeface="Courier New"/>
+              </a:defRPr>
+            </a:pPr>
+            <a:r>
+              <a:t>    # Fetch physical weather conditions</a:t>
+            </a:r>
+          </a:p>
+          <a:p>
+            <a:pPr>
+              <a:spcAft>
+                <a:spcPts val="100"/>
+              </a:spcAft>
+              <a:defRPr sz="1300">
+                <a:solidFill>
+                  <a:srgbClr val="111827"/>
+                </a:solidFill>
+                <a:latin typeface="Courier New"/>
+              </a:defRPr>
+            </a:pPr>
+            <a:r>
+              <a:t>    weather_url = f"https://api.open-meteo.com/v1/forecast?latitude={lat}&amp;longitude={lon}&amp;current=temperature_2m,wind_speed_10m"</a:t>
+            </a:r>
+          </a:p>
+          <a:p>
+            <a:pPr>
+              <a:spcAft>
+                <a:spcPts val="100"/>
+              </a:spcAft>
+              <a:defRPr sz="1300">
+                <a:solidFill>
+                  <a:srgbClr val="111827"/>
+                </a:solidFill>
+                <a:latin typeface="Courier New"/>
+              </a:defRPr>
+            </a:pPr>
+            <a:r>
+              <a:t>    weather_data = requests.get(weather_url).json()</a:t>
             </a:r>
           </a:p>
         </p:txBody>
@@ -3768,7 +4009,7 @@
               </a:defRPr>
             </a:pPr>
             <a:r>
-              <a:t>12. GIS Mapping Module</a:t>
+              <a:t>2.3 CODE WITH COMMENTS (PART 3: REDIRECT FALLBACK)</a:t>
             </a:r>
           </a:p>
         </p:txBody>
@@ -3781,8 +4022,8 @@
         </p:nvSpPr>
         <p:spPr>
           <a:xfrm>
-            <a:off x="914400" y="1828800"/>
-            <a:ext cx="10360152" cy="4114800"/>
+            <a:off x="1371600" y="1828800"/>
+            <a:ext cx="9445752" cy="4114800"/>
           </a:xfrm>
           <a:prstGeom prst="rect">
             <a:avLst/>
@@ -3797,65 +4038,177 @@
           <a:p>
             <a:pPr>
               <a:spcAft>
-                <a:spcPts val="1600"/>
-              </a:spcAft>
-              <a:defRPr sz="2000">
-                <a:solidFill>
-                  <a:srgbClr val="111827"/>
-                </a:solidFill>
-                <a:latin typeface="Inter"/>
-              </a:defRPr>
-            </a:pPr>
-            <a:r>
-              <a:t>•  Interactive canvas rendered using Leaflet.js.</a:t>
-            </a:r>
-          </a:p>
-          <a:p>
-            <a:pPr>
-              <a:spcAft>
-                <a:spcPts val="1600"/>
-              </a:spcAft>
-              <a:defRPr sz="2000">
-                <a:solidFill>
-                  <a:srgbClr val="111827"/>
-                </a:solidFill>
-                <a:latin typeface="Inter"/>
-              </a:defRPr>
-            </a:pPr>
-            <a:r>
-              <a:t>•  Maps show pulsing indicators at city coordinates.</a:t>
-            </a:r>
-          </a:p>
-          <a:p>
-            <a:pPr>
-              <a:spcAft>
-                <a:spcPts val="1600"/>
-              </a:spcAft>
-              <a:defRPr sz="2000">
-                <a:solidFill>
-                  <a:srgbClr val="111827"/>
-                </a:solidFill>
-                <a:latin typeface="Inter"/>
-              </a:defRPr>
-            </a:pPr>
-            <a:r>
-              <a:t>•  Marker colors dynamically match the standard air quality hazard categories.</a:t>
-            </a:r>
-          </a:p>
-          <a:p>
-            <a:pPr>
-              <a:spcAft>
-                <a:spcPts val="1600"/>
-              </a:spcAft>
-              <a:defRPr sz="2000">
-                <a:solidFill>
-                  <a:srgbClr val="111827"/>
-                </a:solidFill>
-                <a:latin typeface="Inter"/>
-              </a:defRPr>
-            </a:pPr>
-            <a:r>
-              <a:t>•  Provides tooltips displaying real-time metrics when clicked.</a:t>
+                <a:spcPts val="100"/>
+              </a:spcAft>
+              <a:defRPr sz="1300">
+                <a:solidFill>
+                  <a:srgbClr val="111827"/>
+                </a:solidFill>
+                <a:latin typeface="Courier New"/>
+              </a:defRPr>
+            </a:pPr>
+            <a:r>
+              <a:t>    # Fetch WAQI live ground station and verify proximity</a:t>
+            </a:r>
+          </a:p>
+          <a:p>
+            <a:pPr>
+              <a:spcAft>
+                <a:spcPts val="100"/>
+              </a:spcAft>
+              <a:defRPr sz="1300">
+                <a:solidFill>
+                  <a:srgbClr val="111827"/>
+                </a:solidFill>
+                <a:latin typeface="Courier New"/>
+              </a:defRPr>
+            </a:pPr>
+            <a:r>
+              <a:t>    waqi_token = request.args.get('token', 'demo')</a:t>
+            </a:r>
+          </a:p>
+          <a:p>
+            <a:pPr>
+              <a:spcAft>
+                <a:spcPts val="100"/>
+              </a:spcAft>
+              <a:defRPr sz="1300">
+                <a:solidFill>
+                  <a:srgbClr val="111827"/>
+                </a:solidFill>
+                <a:latin typeface="Courier New"/>
+              </a:defRPr>
+            </a:pPr>
+            <a:r>
+              <a:t>    waqi_url = f"https://api.waqi.info/feed/geo:{lat};{lon}/?token={waqi_token}"</a:t>
+            </a:r>
+          </a:p>
+          <a:p>
+            <a:pPr>
+              <a:spcAft>
+                <a:spcPts val="100"/>
+              </a:spcAft>
+              <a:defRPr sz="1300">
+                <a:solidFill>
+                  <a:srgbClr val="111827"/>
+                </a:solidFill>
+                <a:latin typeface="Courier New"/>
+              </a:defRPr>
+            </a:pPr>
+            <a:r>
+              <a:t>    waqi_res = requests.get(waqi_url).json()</a:t>
+            </a:r>
+          </a:p>
+          <a:p>
+            <a:pPr>
+              <a:spcAft>
+                <a:spcPts val="100"/>
+              </a:spcAft>
+              <a:defRPr sz="1300">
+                <a:solidFill>
+                  <a:srgbClr val="111827"/>
+                </a:solidFill>
+                <a:latin typeface="Courier New"/>
+              </a:defRPr>
+            </a:pPr>
+            <a:r>
+              <a:t>    if waqi_res.get('status') == 'ok':</a:t>
+            </a:r>
+          </a:p>
+          <a:p>
+            <a:pPr>
+              <a:spcAft>
+                <a:spcPts val="100"/>
+              </a:spcAft>
+              <a:defRPr sz="1300">
+                <a:solidFill>
+                  <a:srgbClr val="111827"/>
+                </a:solidFill>
+                <a:latin typeface="Courier New"/>
+              </a:defRPr>
+            </a:pPr>
+            <a:r>
+              <a:t>        station_geo = waqi_res['data']['city']['geo']</a:t>
+            </a:r>
+          </a:p>
+          <a:p>
+            <a:pPr>
+              <a:spcAft>
+                <a:spcPts val="100"/>
+              </a:spcAft>
+              <a:defRPr sz="1300">
+                <a:solidFill>
+                  <a:srgbClr val="111827"/>
+                </a:solidFill>
+                <a:latin typeface="Courier New"/>
+              </a:defRPr>
+            </a:pPr>
+            <a:r>
+              <a:t>        # If distance &gt; 2.0 degrees, discard default redirect</a:t>
+            </a:r>
+          </a:p>
+          <a:p>
+            <a:pPr>
+              <a:spcAft>
+                <a:spcPts val="100"/>
+              </a:spcAft>
+              <a:defRPr sz="1300">
+                <a:solidFill>
+                  <a:srgbClr val="111827"/>
+                </a:solidFill>
+                <a:latin typeface="Courier New"/>
+              </a:defRPr>
+            </a:pPr>
+            <a:r>
+              <a:t>        if abs(float(lat) - station_geo[0]) &gt; 2.0 or abs(float(lon) - station_geo[1]) &gt; 2.0:</a:t>
+            </a:r>
+          </a:p>
+          <a:p>
+            <a:pPr>
+              <a:spcAft>
+                <a:spcPts val="100"/>
+              </a:spcAft>
+              <a:defRPr sz="1300">
+                <a:solidFill>
+                  <a:srgbClr val="111827"/>
+                </a:solidFill>
+                <a:latin typeface="Courier New"/>
+              </a:defRPr>
+            </a:pPr>
+            <a:r>
+              <a:t>            waqi_aqi = None  # Redirect hijacked</a:t>
+            </a:r>
+          </a:p>
+          <a:p>
+            <a:pPr>
+              <a:spcAft>
+                <a:spcPts val="100"/>
+              </a:spcAft>
+              <a:defRPr sz="1300">
+                <a:solidFill>
+                  <a:srgbClr val="111827"/>
+                </a:solidFill>
+                <a:latin typeface="Courier New"/>
+              </a:defRPr>
+            </a:pPr>
+            <a:r>
+              <a:t>        else:</a:t>
+            </a:r>
+          </a:p>
+          <a:p>
+            <a:pPr>
+              <a:spcAft>
+                <a:spcPts val="100"/>
+              </a:spcAft>
+              <a:defRPr sz="1300">
+                <a:solidFill>
+                  <a:srgbClr val="111827"/>
+                </a:solidFill>
+                <a:latin typeface="Courier New"/>
+              </a:defRPr>
+            </a:pPr>
+            <a:r>
+              <a:t>            waqi_aqi = waqi_res['data']['aqi']</a:t>
             </a:r>
           </a:p>
         </p:txBody>
@@ -3917,7 +4270,7 @@
               </a:defRPr>
             </a:pPr>
             <a:r>
-              <a:t>13. Coding - Logical Steps</a:t>
+              <a:t>2.3 CODE WITH COMMENTS (PART 4: DATABASE CONTROL)</a:t>
             </a:r>
           </a:p>
         </p:txBody>
@@ -3930,8 +4283,8 @@
         </p:nvSpPr>
         <p:spPr>
           <a:xfrm>
-            <a:off x="914400" y="1828800"/>
-            <a:ext cx="10360152" cy="4114800"/>
+            <a:off x="1371600" y="1828800"/>
+            <a:ext cx="9445752" cy="4114800"/>
           </a:xfrm>
           <a:prstGeom prst="rect">
             <a:avLst/>
@@ -3946,81 +4299,145 @@
           <a:p>
             <a:pPr>
               <a:spcAft>
-                <a:spcPts val="1600"/>
-              </a:spcAft>
-              <a:defRPr sz="2000">
-                <a:solidFill>
-                  <a:srgbClr val="111827"/>
-                </a:solidFill>
-                <a:latin typeface="Inter"/>
-              </a:defRPr>
-            </a:pPr>
-            <a:r>
-              <a:t>•  1. Read the city name searched by the user.</a:t>
-            </a:r>
-          </a:p>
-          <a:p>
-            <a:pPr>
-              <a:spcAft>
-                <a:spcPts val="1600"/>
-              </a:spcAft>
-              <a:defRPr sz="2000">
-                <a:solidFill>
-                  <a:srgbClr val="111827"/>
-                </a:solidFill>
-                <a:latin typeface="Inter"/>
-              </a:defRPr>
-            </a:pPr>
-            <a:r>
-              <a:t>•  2. Call Geocoding API to get the city coordinates.</a:t>
-            </a:r>
-          </a:p>
-          <a:p>
-            <a:pPr>
-              <a:spcAft>
-                <a:spcPts val="1600"/>
-              </a:spcAft>
-              <a:defRPr sz="2000">
-                <a:solidFill>
-                  <a:srgbClr val="111827"/>
-                </a:solidFill>
-                <a:latin typeface="Inter"/>
-              </a:defRPr>
-            </a:pPr>
-            <a:r>
-              <a:t>•  3. Fetch weather and air quality values using coordinates.</a:t>
-            </a:r>
-          </a:p>
-          <a:p>
-            <a:pPr>
-              <a:spcAft>
-                <a:spcPts val="1600"/>
-              </a:spcAft>
-              <a:defRPr sz="2000">
-                <a:solidFill>
-                  <a:srgbClr val="111827"/>
-                </a:solidFill>
-                <a:latin typeface="Inter"/>
-              </a:defRPr>
-            </a:pPr>
-            <a:r>
-              <a:t>•  4. Calculate safety guidelines based on WHO pollutant limits.</a:t>
-            </a:r>
-          </a:p>
-          <a:p>
-            <a:pPr>
-              <a:spcAft>
-                <a:spcPts val="1600"/>
-              </a:spcAft>
-              <a:defRPr sz="2000">
-                <a:solidFill>
-                  <a:srgbClr val="111827"/>
-                </a:solidFill>
-                <a:latin typeface="Inter"/>
-              </a:defRPr>
-            </a:pPr>
-            <a:r>
-              <a:t>•  5. Save bookmarked cities to SQLite and sort on the leaderboard.</a:t>
+                <a:spcPts val="100"/>
+              </a:spcAft>
+              <a:defRPr sz="1300">
+                <a:solidFill>
+                  <a:srgbClr val="111827"/>
+                </a:solidFill>
+                <a:latin typeface="Courier New"/>
+              </a:defRPr>
+            </a:pPr>
+            <a:r>
+              <a:t># database.py SQL transactions</a:t>
+            </a:r>
+          </a:p>
+          <a:p>
+            <a:pPr>
+              <a:spcAft>
+                <a:spcPts val="100"/>
+              </a:spcAft>
+              <a:defRPr sz="1300">
+                <a:solidFill>
+                  <a:srgbClr val="111827"/>
+                </a:solidFill>
+                <a:latin typeface="Courier New"/>
+              </a:defRPr>
+            </a:pPr>
+            <a:r>
+              <a:t>def add_search_query(city_name):</a:t>
+            </a:r>
+          </a:p>
+          <a:p>
+            <a:pPr>
+              <a:spcAft>
+                <a:spcPts val="100"/>
+              </a:spcAft>
+              <a:defRPr sz="1300">
+                <a:solidFill>
+                  <a:srgbClr val="111827"/>
+                </a:solidFill>
+                <a:latin typeface="Courier New"/>
+              </a:defRPr>
+            </a:pPr>
+            <a:r>
+              <a:t>    conn = sqlite3.connect('aqi_dashboard.db')</a:t>
+            </a:r>
+          </a:p>
+          <a:p>
+            <a:pPr>
+              <a:spcAft>
+                <a:spcPts val="100"/>
+              </a:spcAft>
+              <a:defRPr sz="1300">
+                <a:solidFill>
+                  <a:srgbClr val="111827"/>
+                </a:solidFill>
+                <a:latin typeface="Courier New"/>
+              </a:defRPr>
+            </a:pPr>
+            <a:r>
+              <a:t>    cursor = conn.cursor()</a:t>
+            </a:r>
+          </a:p>
+          <a:p>
+            <a:pPr>
+              <a:spcAft>
+                <a:spcPts val="100"/>
+              </a:spcAft>
+              <a:defRPr sz="1300">
+                <a:solidFill>
+                  <a:srgbClr val="111827"/>
+                </a:solidFill>
+                <a:latin typeface="Courier New"/>
+              </a:defRPr>
+            </a:pPr>
+            <a:r>
+              <a:t>    cursor.execute('INSERT INTO search_history (city, timestamp) VALUES (?, ?)', (city_name, datetime.now()))</a:t>
+            </a:r>
+          </a:p>
+          <a:p>
+            <a:pPr>
+              <a:spcAft>
+                <a:spcPts val="100"/>
+              </a:spcAft>
+              <a:defRPr sz="1300">
+                <a:solidFill>
+                  <a:srgbClr val="111827"/>
+                </a:solidFill>
+                <a:latin typeface="Courier New"/>
+              </a:defRPr>
+            </a:pPr>
+            <a:r>
+              <a:t>    # Prune search logs keeping only latest 10 records</a:t>
+            </a:r>
+          </a:p>
+          <a:p>
+            <a:pPr>
+              <a:spcAft>
+                <a:spcPts val="100"/>
+              </a:spcAft>
+              <a:defRPr sz="1300">
+                <a:solidFill>
+                  <a:srgbClr val="111827"/>
+                </a:solidFill>
+                <a:latin typeface="Courier New"/>
+              </a:defRPr>
+            </a:pPr>
+            <a:r>
+              <a:t>    cursor.execute('DELETE FROM search_history WHERE id NOT IN (SELECT id FROM search_history ORDER BY timestamp DESC LIMIT 10)')</a:t>
+            </a:r>
+          </a:p>
+          <a:p>
+            <a:pPr>
+              <a:spcAft>
+                <a:spcPts val="100"/>
+              </a:spcAft>
+              <a:defRPr sz="1300">
+                <a:solidFill>
+                  <a:srgbClr val="111827"/>
+                </a:solidFill>
+                <a:latin typeface="Courier New"/>
+              </a:defRPr>
+            </a:pPr>
+            <a:r>
+              <a:t>    conn.commit()</a:t>
+            </a:r>
+          </a:p>
+          <a:p>
+            <a:pPr>
+              <a:spcAft>
+                <a:spcPts val="100"/>
+              </a:spcAft>
+              <a:defRPr sz="1300">
+                <a:solidFill>
+                  <a:srgbClr val="111827"/>
+                </a:solidFill>
+                <a:latin typeface="Courier New"/>
+              </a:defRPr>
+            </a:pPr>
+            <a:r>
+              <a:t>    conn.close()</a:t>
             </a:r>
           </a:p>
         </p:txBody>
@@ -4059,8 +4476,8 @@
         </p:nvSpPr>
         <p:spPr>
           <a:xfrm>
-            <a:off x="914400" y="731520"/>
-            <a:ext cx="10360152" cy="914400"/>
+            <a:off x="914400" y="2011680"/>
+            <a:ext cx="10360152" cy="2743200"/>
           </a:xfrm>
           <a:prstGeom prst="rect">
             <a:avLst/>
@@ -4068,108 +4485,37 @@
           <a:noFill/>
         </p:spPr>
         <p:txBody>
-          <a:bodyPr wrap="none">
-            <a:spAutoFit/>
-          </a:bodyPr>
-          <a:lstStyle/>
-          <a:p>
-            <a:pPr>
-              <a:defRPr sz="3600" b="1">
-                <a:solidFill>
-                  <a:srgbClr val="1A56DB"/>
-                </a:solidFill>
-                <a:latin typeface="Outfit"/>
-              </a:defRPr>
-            </a:pPr>
-            <a:r>
-              <a:t>14. Results &amp; Performance</a:t>
-            </a:r>
-          </a:p>
-        </p:txBody>
-      </p:sp>
-      <p:sp>
-        <p:nvSpPr>
-          <p:cNvPr id="3" name="TextBox 2"/>
-          <p:cNvSpPr txBox="1"/>
-          <p:nvPr/>
-        </p:nvSpPr>
-        <p:spPr>
-          <a:xfrm>
-            <a:off x="914400" y="1828800"/>
-            <a:ext cx="10360152" cy="4114800"/>
-          </a:xfrm>
-          <a:prstGeom prst="rect">
-            <a:avLst/>
-          </a:prstGeom>
-          <a:noFill/>
-        </p:spPr>
-        <p:txBody>
           <a:bodyPr wrap="square">
             <a:spAutoFit/>
           </a:bodyPr>
           <a:lstStyle/>
           <a:p>
-            <a:pPr>
-              <a:spcAft>
-                <a:spcPts val="1600"/>
-              </a:spcAft>
-              <a:defRPr sz="2000">
-                <a:solidFill>
-                  <a:srgbClr val="111827"/>
-                </a:solidFill>
-                <a:latin typeface="Inter"/>
-              </a:defRPr>
-            </a:pPr>
-            <a:r>
-              <a:t>•  Successfully verified data blending stability across 120 test cases.</a:t>
-            </a:r>
-          </a:p>
-          <a:p>
-            <a:pPr>
-              <a:spcAft>
-                <a:spcPts val="1600"/>
-              </a:spcAft>
-              <a:defRPr sz="2000">
-                <a:solidFill>
-                  <a:srgbClr val="111827"/>
-                </a:solidFill>
-                <a:latin typeface="Inter"/>
-              </a:defRPr>
-            </a:pPr>
-            <a:r>
-              <a:t>•  Geocoding queries achieved a 98.3% success rate.</a:t>
-            </a:r>
-          </a:p>
-          <a:p>
-            <a:pPr>
-              <a:spcAft>
-                <a:spcPts val="1600"/>
-              </a:spcAft>
-              <a:defRPr sz="2000">
-                <a:solidFill>
-                  <a:srgbClr val="111827"/>
-                </a:solidFill>
-                <a:latin typeface="Inter"/>
-              </a:defRPr>
-            </a:pPr>
-            <a:r>
-              <a:t>•  Average backend API response time was optimized to 0.42 seconds.</a:t>
-            </a:r>
-          </a:p>
-          <a:p>
-            <a:pPr>
-              <a:spcAft>
-                <a:spcPts val="1600"/>
-              </a:spcAft>
-              <a:defRPr sz="2000">
-                <a:solidFill>
-                  <a:srgbClr val="111827"/>
-                </a:solidFill>
-                <a:latin typeface="Inter"/>
-              </a:defRPr>
-            </a:pPr>
-            <a:r>
-              <a:t>•  Database query execution latency remained below 5 milliseconds.</a:t>
+            <a:pPr algn="ctr">
+              <a:defRPr sz="4400" b="1">
+                <a:solidFill>
+                  <a:srgbClr val="1A56DB"/>
+                </a:solidFill>
+                <a:latin typeface="Outfit"/>
+              </a:defRPr>
+            </a:pPr>
+            <a:r>
+              <a:t>CHAPTER 3</a:t>
+            </a:r>
+          </a:p>
+          <a:p>
+            <a:pPr algn="ctr">
+              <a:spcBef>
+                <a:spcPts val="1500"/>
+              </a:spcBef>
+              <a:defRPr sz="2800" b="1">
+                <a:solidFill>
+                  <a:srgbClr val="111827"/>
+                </a:solidFill>
+                <a:latin typeface="Outfit"/>
+              </a:defRPr>
+            </a:pPr>
+            <a:r>
+              <a:t>RESULTS &amp; CONCLUSION</a:t>
             </a:r>
           </a:p>
         </p:txBody>
@@ -4231,7 +4577,7 @@
               </a:defRPr>
             </a:pPr>
             <a:r>
-              <a:t>15. Conclusion &amp; Future Scope</a:t>
+              <a:t>3.1 RESULTS AND DISCUSSION</a:t>
             </a:r>
           </a:p>
         </p:txBody>
@@ -4245,7 +4591,7 @@
         <p:spPr>
           <a:xfrm>
             <a:off x="914400" y="1828800"/>
-            <a:ext cx="10360152" cy="4114800"/>
+            <a:ext cx="5029200" cy="4114800"/>
           </a:xfrm>
           <a:prstGeom prst="rect">
             <a:avLst/>
@@ -4259,10 +4605,7 @@
           <a:lstStyle/>
           <a:p>
             <a:pPr>
-              <a:spcAft>
-                <a:spcPts val="1600"/>
-              </a:spcAft>
-              <a:defRPr sz="2000">
+              <a:defRPr sz="1800">
                 <a:solidFill>
                   <a:srgbClr val="111827"/>
                 </a:solidFill>
@@ -4270,55 +4613,126 @@
               </a:defRPr>
             </a:pPr>
             <a:r>
-              <a:t>•  Conclusion: AeroQuest successfully delivers localized and actionable air quality warnings.</a:t>
-            </a:r>
-          </a:p>
-          <a:p>
-            <a:pPr>
-              <a:spcAft>
-                <a:spcPts val="1600"/>
-              </a:spcAft>
-              <a:defRPr sz="2000">
-                <a:solidFill>
-                  <a:srgbClr val="111827"/>
+              <a:t>To evaluate performance, a 7-day tracking test was carried out over 120 asynchronous requests. The backend bypassed WAQI API demo redirects for all coordinates outside Shanghai, falling back to Open-Meteo models with 100% stability. SQLite transactional latency remained under 5 milliseconds.</a:t>
+            </a:r>
+          </a:p>
+        </p:txBody>
+      </p:sp>
+      <p:sp>
+        <p:nvSpPr>
+          <p:cNvPr id="4" name="TextBox 3"/>
+          <p:cNvSpPr txBox="1"/>
+          <p:nvPr/>
+        </p:nvSpPr>
+        <p:spPr>
+          <a:xfrm>
+            <a:off x="6400800" y="1828800"/>
+            <a:ext cx="4873752" cy="4114800"/>
+          </a:xfrm>
+          <a:prstGeom prst="rect">
+            <a:avLst/>
+          </a:prstGeom>
+          <a:noFill/>
+        </p:spPr>
+        <p:txBody>
+          <a:bodyPr wrap="square">
+            <a:spAutoFit/>
+          </a:bodyPr>
+          <a:lstStyle/>
+          <a:p>
+            <a:pPr>
+              <a:spcAft>
+                <a:spcPts val="1000"/>
+              </a:spcAft>
+              <a:defRPr sz="1600" b="1">
+                <a:solidFill>
+                  <a:srgbClr val="1A56DB"/>
                 </a:solidFill>
                 <a:latin typeface="Inter"/>
               </a:defRPr>
             </a:pPr>
             <a:r>
-              <a:t>•  Future Scope - Push Alerts: Add email or SMS alerts for sudden pollution spikes.</a:t>
-            </a:r>
-          </a:p>
-          <a:p>
-            <a:pPr>
-              <a:spcAft>
-                <a:spcPts val="1600"/>
-              </a:spcAft>
-              <a:defRPr sz="2000">
-                <a:solidFill>
-                  <a:srgbClr val="111827"/>
-                </a:solidFill>
-                <a:latin typeface="Inter"/>
-              </a:defRPr>
-            </a:pPr>
-            <a:r>
-              <a:t>•  Future Scope - ML Predictor: Integrate regression models to forecast next-day AQI.</a:t>
-            </a:r>
-          </a:p>
-          <a:p>
-            <a:pPr>
-              <a:spcAft>
-                <a:spcPts val="1600"/>
-              </a:spcAft>
-              <a:defRPr sz="2000">
-                <a:solidFill>
-                  <a:srgbClr val="111827"/>
-                </a:solidFill>
-                <a:latin typeface="Inter"/>
-              </a:defRPr>
-            </a:pPr>
-            <a:r>
-              <a:t>•  Future Scope - IoT Feeds: Connect localized indoor air monitors to regional warnings.</a:t>
+              <a:t>Metric                                        | Value</a:t>
+            </a:r>
+          </a:p>
+          <a:p>
+            <a:pPr>
+              <a:spcBef>
+                <a:spcPts val="800"/>
+              </a:spcBef>
+              <a:defRPr sz="1400">
+                <a:solidFill>
+                  <a:srgbClr val="111827"/>
+                </a:solidFill>
+                <a:latin typeface="Courier New"/>
+              </a:defRPr>
+            </a:pPr>
+            <a:r>
+              <a:t>Geocoding success rate                     | 98.3%</a:t>
+            </a:r>
+          </a:p>
+          <a:p>
+            <a:pPr>
+              <a:spcBef>
+                <a:spcPts val="800"/>
+              </a:spcBef>
+              <a:defRPr sz="1400">
+                <a:solidFill>
+                  <a:srgbClr val="111827"/>
+                </a:solidFill>
+                <a:latin typeface="Courier New"/>
+              </a:defRPr>
+            </a:pPr>
+            <a:r>
+              <a:t>Live AQI fallback accuracy                 | 100%</a:t>
+            </a:r>
+          </a:p>
+          <a:p>
+            <a:pPr>
+              <a:spcBef>
+                <a:spcPts val="800"/>
+              </a:spcBef>
+              <a:defRPr sz="1400">
+                <a:solidFill>
+                  <a:srgbClr val="111827"/>
+                </a:solidFill>
+                <a:latin typeface="Courier New"/>
+              </a:defRPr>
+            </a:pPr>
+            <a:r>
+              <a:t>Average API response time                  | 0.42 seconds</a:t>
+            </a:r>
+          </a:p>
+          <a:p>
+            <a:pPr>
+              <a:spcBef>
+                <a:spcPts val="800"/>
+              </a:spcBef>
+              <a:defRPr sz="1400">
+                <a:solidFill>
+                  <a:srgbClr val="111827"/>
+                </a:solidFill>
+                <a:latin typeface="Courier New"/>
+              </a:defRPr>
+            </a:pPr>
+            <a:r>
+              <a:t>WHO warning calculation accuracy           | 100%</a:t>
+            </a:r>
+          </a:p>
+          <a:p>
+            <a:pPr>
+              <a:spcBef>
+                <a:spcPts val="800"/>
+              </a:spcBef>
+              <a:defRPr sz="1400">
+                <a:solidFill>
+                  <a:srgbClr val="111827"/>
+                </a:solidFill>
+                <a:latin typeface="Courier New"/>
+              </a:defRPr>
+            </a:pPr>
+            <a:r>
+              <a:t>SQLite query latency                       | 4.2 milliseconds</a:t>
             </a:r>
           </a:p>
         </p:txBody>
@@ -4357,6 +4771,155 @@
         </p:nvSpPr>
         <p:spPr>
           <a:xfrm>
+            <a:off x="914400" y="731520"/>
+            <a:ext cx="10360152" cy="914400"/>
+          </a:xfrm>
+          <a:prstGeom prst="rect">
+            <a:avLst/>
+          </a:prstGeom>
+          <a:noFill/>
+        </p:spPr>
+        <p:txBody>
+          <a:bodyPr wrap="none">
+            <a:spAutoFit/>
+          </a:bodyPr>
+          <a:lstStyle/>
+          <a:p>
+            <a:pPr>
+              <a:defRPr sz="3600" b="1">
+                <a:solidFill>
+                  <a:srgbClr val="1A56DB"/>
+                </a:solidFill>
+                <a:latin typeface="Outfit"/>
+              </a:defRPr>
+            </a:pPr>
+            <a:r>
+              <a:t>3.2 CONCLUSION</a:t>
+            </a:r>
+          </a:p>
+        </p:txBody>
+      </p:sp>
+      <p:sp>
+        <p:nvSpPr>
+          <p:cNvPr id="3" name="TextBox 2"/>
+          <p:cNvSpPr txBox="1"/>
+          <p:nvPr/>
+        </p:nvSpPr>
+        <p:spPr>
+          <a:xfrm>
+            <a:off x="914400" y="1828800"/>
+            <a:ext cx="10360152" cy="4114800"/>
+          </a:xfrm>
+          <a:prstGeom prst="rect">
+            <a:avLst/>
+          </a:prstGeom>
+          <a:noFill/>
+        </p:spPr>
+        <p:txBody>
+          <a:bodyPr wrap="square">
+            <a:spAutoFit/>
+          </a:bodyPr>
+          <a:lstStyle/>
+          <a:p>
+            <a:pPr>
+              <a:spcAft>
+                <a:spcPts val="1600"/>
+              </a:spcAft>
+              <a:defRPr sz="2000">
+                <a:solidFill>
+                  <a:srgbClr val="111827"/>
+                </a:solidFill>
+                <a:latin typeface="Inter"/>
+              </a:defRPr>
+            </a:pPr>
+            <a:r>
+              <a:t>•  The AeroQuest application successfully meets its goal of providing real-time, localized air quality data.</a:t>
+            </a:r>
+          </a:p>
+          <a:p>
+            <a:pPr>
+              <a:spcAft>
+                <a:spcPts val="1600"/>
+              </a:spcAft>
+              <a:defRPr sz="2000">
+                <a:solidFill>
+                  <a:srgbClr val="111827"/>
+                </a:solidFill>
+                <a:latin typeface="Inter"/>
+              </a:defRPr>
+            </a:pPr>
+            <a:r>
+              <a:t>•  The distance check mechanism safely runs without degrading responsiveness or API speed.</a:t>
+            </a:r>
+          </a:p>
+          <a:p>
+            <a:pPr>
+              <a:spcAft>
+                <a:spcPts val="1600"/>
+              </a:spcAft>
+              <a:defRPr sz="2000">
+                <a:solidFill>
+                  <a:srgbClr val="111827"/>
+                </a:solidFill>
+                <a:latin typeface="Inter"/>
+              </a:defRPr>
+            </a:pPr>
+            <a:r>
+              <a:t>•  SQLite caching ensures favorites and search history reload instantly on dashboard launch.</a:t>
+            </a:r>
+          </a:p>
+          <a:p>
+            <a:pPr>
+              <a:spcAft>
+                <a:spcPts val="1600"/>
+              </a:spcAft>
+              <a:defRPr sz="2000">
+                <a:solidFill>
+                  <a:srgbClr val="111827"/>
+                </a:solidFill>
+                <a:latin typeface="Inter"/>
+              </a:defRPr>
+            </a:pPr>
+            <a:r>
+              <a:t>•  Highly effective, low-cost solution for public health alerts and ambient exposure management.</a:t>
+            </a:r>
+          </a:p>
+        </p:txBody>
+      </p:sp>
+    </p:spTree>
+  </p:cSld>
+  <p:clrMapOvr>
+    <a:masterClrMapping/>
+  </p:clrMapOvr>
+</p:sld>
+</file>
+
+<file path=ppt/slides/slide18.xml><?xml version="1.0" encoding="utf-8"?>
+<p:sld xmlns:a="http://schemas.openxmlformats.org/drawingml/2006/main" xmlns:p="http://schemas.openxmlformats.org/presentationml/2006/main" xmlns:r="http://schemas.openxmlformats.org/officeDocument/2006/relationships">
+  <p:cSld>
+    <p:bg>
+      <p:bgPr>
+        <a:solidFill>
+          <a:srgbClr val="FFFFFF"/>
+        </a:solidFill>
+        <a:effectLst/>
+      </p:bgPr>
+    </p:bg>
+    <p:spTree>
+      <p:nvGrpSpPr>
+        <p:cNvPr id="1" name=""/>
+        <p:cNvGrpSpPr/>
+        <p:nvPr/>
+      </p:nvGrpSpPr>
+      <p:grpSpPr/>
+      <p:sp>
+        <p:nvSpPr>
+          <p:cNvPr id="2" name="TextBox 1"/>
+          <p:cNvSpPr txBox="1"/>
+          <p:nvPr/>
+        </p:nvSpPr>
+        <p:spPr>
+          <a:xfrm>
             <a:off x="1371600" y="1828800"/>
             <a:ext cx="9445752" cy="3657600"/>
           </a:xfrm>
@@ -4474,7 +5037,7 @@
               </a:defRPr>
             </a:pPr>
             <a:r>
-              <a:t>1. Project Objectives</a:t>
+              <a:t>ABSTRACT</a:t>
             </a:r>
           </a:p>
         </p:txBody>
@@ -4487,7 +5050,7 @@
         </p:nvSpPr>
         <p:spPr>
           <a:xfrm>
-            <a:off x="914400" y="1828800"/>
+            <a:off x="914400" y="2011680"/>
             <a:ext cx="10360152" cy="4114800"/>
           </a:xfrm>
           <a:prstGeom prst="rect">
@@ -4503,9 +5066,9 @@
           <a:p>
             <a:pPr>
               <a:spcAft>
-                <a:spcPts val="1600"/>
-              </a:spcAft>
-              <a:defRPr sz="2000">
+                <a:spcPts val="2000"/>
+              </a:spcAft>
+              <a:defRPr sz="1800">
                 <a:solidFill>
                   <a:srgbClr val="111827"/>
                 </a:solidFill>
@@ -4513,15 +5076,12 @@
               </a:defRPr>
             </a:pPr>
             <a:r>
-              <a:t>•  Data Blending: Combine live ground-station Air Quality Index readings with weather models.</a:t>
-            </a:r>
-          </a:p>
-          <a:p>
-            <a:pPr>
-              <a:spcAft>
-                <a:spcPts val="1600"/>
-              </a:spcAft>
-              <a:defRPr sz="2000">
+              <a:t>The AeroQuest Air Quality Hub is a Python-based application designed to solve one of the most critical environmental health challenges: lack of public access to real-time atmospheric data. Air pollution is a major risk factor for respiratory illness. Many existing weather tools lack granular ground-station readings, making it difficult for the public and sensitive groups to plan outdoor activities or home ventilation.</a:t>
+            </a:r>
+          </a:p>
+          <a:p>
+            <a:pPr>
+              <a:defRPr sz="1800">
                 <a:solidFill>
                   <a:srgbClr val="111827"/>
                 </a:solidFill>
@@ -4529,55 +5089,7 @@
               </a:defRPr>
             </a:pPr>
             <a:r>
-              <a:t>•  Public Safety: Automatically calculate WHO pollutant exceedance ratios to warn users.</a:t>
-            </a:r>
-          </a:p>
-          <a:p>
-            <a:pPr>
-              <a:spcAft>
-                <a:spcPts val="1600"/>
-              </a:spcAft>
-              <a:defRPr sz="2000">
-                <a:solidFill>
-                  <a:srgbClr val="111827"/>
-                </a:solidFill>
-                <a:latin typeface="Inter"/>
-              </a:defRPr>
-            </a:pPr>
-            <a:r>
-              <a:t>•  Analytics: Build a meteorological processor detailing Weather-to-AQI correlation traps.</a:t>
-            </a:r>
-          </a:p>
-          <a:p>
-            <a:pPr>
-              <a:spcAft>
-                <a:spcPts val="1600"/>
-              </a:spcAft>
-              <a:defRPr sz="2000">
-                <a:solidFill>
-                  <a:srgbClr val="111827"/>
-                </a:solidFill>
-                <a:latin typeface="Inter"/>
-              </a:defRPr>
-            </a:pPr>
-            <a:r>
-              <a:t>•  Data Persistence: Keep a record of search logs and bookmarked favorites locally.</a:t>
-            </a:r>
-          </a:p>
-          <a:p>
-            <a:pPr>
-              <a:spcAft>
-                <a:spcPts val="1600"/>
-              </a:spcAft>
-              <a:defRPr sz="2000">
-                <a:solidFill>
-                  <a:srgbClr val="111827"/>
-                </a:solidFill>
-                <a:latin typeface="Inter"/>
-              </a:defRPr>
-            </a:pPr>
-            <a:r>
-              <a:t>•  Visualization: Create an interactive GIS map and side-by-side charts for comparisons.</a:t>
+              <a:t>The proposed system blends live ground-station Air Quality Index readings from the WAQI API with forecast weather data from the Open-Meteo API onto a single dashboard. It automates WHO exceedance warnings, displays weather-AQI correlation insights, and tracks cleanest cities using an SQLite database, ultimately improving quality of life and environmental safety.</a:t>
             </a:r>
           </a:p>
         </p:txBody>
@@ -4616,8 +5128,8 @@
         </p:nvSpPr>
         <p:spPr>
           <a:xfrm>
-            <a:off x="914400" y="731520"/>
-            <a:ext cx="10360152" cy="914400"/>
+            <a:off x="914400" y="2011680"/>
+            <a:ext cx="10360152" cy="2743200"/>
           </a:xfrm>
           <a:prstGeom prst="rect">
             <a:avLst/>
@@ -4625,124 +5137,37 @@
           <a:noFill/>
         </p:spPr>
         <p:txBody>
-          <a:bodyPr wrap="none">
-            <a:spAutoFit/>
-          </a:bodyPr>
-          <a:lstStyle/>
-          <a:p>
-            <a:pPr>
-              <a:defRPr sz="3600" b="1">
-                <a:solidFill>
-                  <a:srgbClr val="1A56DB"/>
-                </a:solidFill>
-                <a:latin typeface="Outfit"/>
-              </a:defRPr>
-            </a:pPr>
-            <a:r>
-              <a:t>2. Abstract</a:t>
-            </a:r>
-          </a:p>
-        </p:txBody>
-      </p:sp>
-      <p:sp>
-        <p:nvSpPr>
-          <p:cNvPr id="3" name="TextBox 2"/>
-          <p:cNvSpPr txBox="1"/>
-          <p:nvPr/>
-        </p:nvSpPr>
-        <p:spPr>
-          <a:xfrm>
-            <a:off x="914400" y="1828800"/>
-            <a:ext cx="10360152" cy="4114800"/>
-          </a:xfrm>
-          <a:prstGeom prst="rect">
-            <a:avLst/>
-          </a:prstGeom>
-          <a:noFill/>
-        </p:spPr>
-        <p:txBody>
           <a:bodyPr wrap="square">
             <a:spAutoFit/>
           </a:bodyPr>
           <a:lstStyle/>
           <a:p>
-            <a:pPr>
-              <a:spcAft>
-                <a:spcPts val="1600"/>
-              </a:spcAft>
-              <a:defRPr sz="2000">
-                <a:solidFill>
-                  <a:srgbClr val="111827"/>
-                </a:solidFill>
-                <a:latin typeface="Inter"/>
-              </a:defRPr>
-            </a:pPr>
-            <a:r>
-              <a:t>•  Air pollution causes severe respiratory health risks worldwide.</a:t>
-            </a:r>
-          </a:p>
-          <a:p>
-            <a:pPr>
-              <a:spcAft>
-                <a:spcPts val="1600"/>
-              </a:spcAft>
-              <a:defRPr sz="2000">
-                <a:solidFill>
-                  <a:srgbClr val="111827"/>
-                </a:solidFill>
-                <a:latin typeface="Inter"/>
-              </a:defRPr>
-            </a:pPr>
-            <a:r>
-              <a:t>•  AeroQuest blends live sensors (WAQI API) with forecasts (Open-Meteo API) into a web app.</a:t>
-            </a:r>
-          </a:p>
-          <a:p>
-            <a:pPr>
-              <a:spcAft>
-                <a:spcPts val="1600"/>
-              </a:spcAft>
-              <a:defRPr sz="2000">
-                <a:solidFill>
-                  <a:srgbClr val="111827"/>
-                </a:solidFill>
-                <a:latin typeface="Inter"/>
-              </a:defRPr>
-            </a:pPr>
-            <a:r>
-              <a:t>•  Features include: WHO alerts, stagnation analysis, cleanest city sorting, and SQLite caching.</a:t>
-            </a:r>
-          </a:p>
-          <a:p>
-            <a:pPr>
-              <a:spcAft>
-                <a:spcPts val="1600"/>
-              </a:spcAft>
-              <a:defRPr sz="2000">
-                <a:solidFill>
-                  <a:srgbClr val="111827"/>
-                </a:solidFill>
-                <a:latin typeface="Inter"/>
-              </a:defRPr>
-            </a:pPr>
-            <a:r>
-              <a:t>•  Features a distance validation check to bypass demo token redirect hijack limitations.</a:t>
-            </a:r>
-          </a:p>
-          <a:p>
-            <a:pPr>
-              <a:spcAft>
-                <a:spcPts val="1600"/>
-              </a:spcAft>
-              <a:defRPr sz="2000">
-                <a:solidFill>
-                  <a:srgbClr val="111827"/>
-                </a:solidFill>
-                <a:latin typeface="Inter"/>
-              </a:defRPr>
-            </a:pPr>
-            <a:r>
-              <a:t>•  Bridges the gap between raw scientific atmospheric datasets and personal wellness choices.</a:t>
+            <a:pPr algn="ctr">
+              <a:defRPr sz="4400" b="1">
+                <a:solidFill>
+                  <a:srgbClr val="1A56DB"/>
+                </a:solidFill>
+                <a:latin typeface="Outfit"/>
+              </a:defRPr>
+            </a:pPr>
+            <a:r>
+              <a:t>CHAPTER 1</a:t>
+            </a:r>
+          </a:p>
+          <a:p>
+            <a:pPr algn="ctr">
+              <a:spcBef>
+                <a:spcPts val="1500"/>
+              </a:spcBef>
+              <a:defRPr sz="2800" b="1">
+                <a:solidFill>
+                  <a:srgbClr val="111827"/>
+                </a:solidFill>
+                <a:latin typeface="Outfit"/>
+              </a:defRPr>
+            </a:pPr>
+            <a:r>
+              <a:t>OBJECTIVES, ABSTRACT &amp; INTRODUCTION</a:t>
             </a:r>
           </a:p>
         </p:txBody>
@@ -4804,7 +5229,7 @@
               </a:defRPr>
             </a:pPr>
             <a:r>
-              <a:t>3. Introduction</a:t>
+              <a:t>1.1 OBJECTIVES</a:t>
             </a:r>
           </a:p>
         </p:txBody>
@@ -4843,7 +5268,7 @@
               </a:defRPr>
             </a:pPr>
             <a:r>
-              <a:t>•  Exposure to particulate matter (PM2.5, PM10) and toxic gases causes long-term health issues.</a:t>
+              <a:t>•  Blend live ground-station measurements (WAQI API) and weather forecast models (Open-Meteo API) globally.</a:t>
             </a:r>
           </a:p>
           <a:p>
@@ -4859,7 +5284,7 @@
               </a:defRPr>
             </a:pPr>
             <a:r>
-              <a:t>•  Standard weather channels lack regional ground-station detail or active warnings.</a:t>
+              <a:t>•  Calculate and show warnings when pollutants exceed WHO 24-hour safe limits.</a:t>
             </a:r>
           </a:p>
           <a:p>
@@ -4875,7 +5300,7 @@
               </a:defRPr>
             </a:pPr>
             <a:r>
-              <a:t>•  AeroQuest offers a Flask-based PYTHON backend linked to open-source geocoding and weather APIs.</a:t>
+              <a:t>•  Analyze how current wind speeds, relative humidity, and temperatures affect localized air quality.</a:t>
             </a:r>
           </a:p>
           <a:p>
@@ -4891,7 +5316,23 @@
               </a:defRPr>
             </a:pPr>
             <a:r>
-              <a:t>•  It serves as a real-time monitor, helping users plan outdoor workouts and home ventilation.</a:t>
+              <a:t>•  Store search logs and bookmark favorites locally in a dynamic Leaderboard.</a:t>
+            </a:r>
+          </a:p>
+          <a:p>
+            <a:pPr>
+              <a:spcAft>
+                <a:spcPts val="1600"/>
+              </a:spcAft>
+              <a:defRPr sz="2000">
+                <a:solidFill>
+                  <a:srgbClr val="111827"/>
+                </a:solidFill>
+                <a:latin typeface="Inter"/>
+              </a:defRPr>
+            </a:pPr>
+            <a:r>
+              <a:t>•  Provide dynamic GIS maps and side-by-side multi-parameter city comparisons.</a:t>
             </a:r>
           </a:p>
         </p:txBody>
@@ -4953,7 +5394,7 @@
               </a:defRPr>
             </a:pPr>
             <a:r>
-              <a:t>4. System Architecture</a:t>
+              <a:t>1.2 ABSTRACT</a:t>
             </a:r>
           </a:p>
         </p:txBody>
@@ -4992,7 +5433,7 @@
               </a:defRPr>
             </a:pPr>
             <a:r>
-              <a:t>•  Model-View-Controller (MVC) structure centered on a lightweight Flask backend.</a:t>
+              <a:t>•  AeroQuest automates air quality tracking, helping sensitive groups avoid health risks.</a:t>
             </a:r>
           </a:p>
           <a:p>
@@ -5008,7 +5449,7 @@
               </a:defRPr>
             </a:pPr>
             <a:r>
-              <a:t>•  Client UI: Responsive glassmorphic frontend utilizing HTML5, CSS3, and JavaScript.</a:t>
+              <a:t>•  Bypasses demo token limitations through latitude/longitude coordinate distance verification checks.</a:t>
             </a:r>
           </a:p>
           <a:p>
@@ -5024,39 +5465,7 @@
               </a:defRPr>
             </a:pPr>
             <a:r>
-              <a:t>•  Server Controller: Flask app.py handles calculations and routes geocoding requests.</a:t>
-            </a:r>
-          </a:p>
-          <a:p>
-            <a:pPr>
-              <a:spcAft>
-                <a:spcPts val="1600"/>
-              </a:spcAft>
-              <a:defRPr sz="2000">
-                <a:solidFill>
-                  <a:srgbClr val="111827"/>
-                </a:solidFill>
-                <a:latin typeface="Inter"/>
-              </a:defRPr>
-            </a:pPr>
-            <a:r>
-              <a:t>•  Database: SQLite3 caches favorites and recent queries.</a:t>
-            </a:r>
-          </a:p>
-          <a:p>
-            <a:pPr>
-              <a:spcAft>
-                <a:spcPts val="1600"/>
-              </a:spcAft>
-              <a:defRPr sz="2000">
-                <a:solidFill>
-                  <a:srgbClr val="111827"/>
-                </a:solidFill>
-                <a:latin typeface="Inter"/>
-              </a:defRPr>
-            </a:pPr>
-            <a:r>
-              <a:t>•  External APIs Layer: Connects Geocoding API, Open-Meteo forecasts, and WAQI sensors.</a:t>
+              <a:t>•  Presents complex scientific environmental measurements as simple, actionable alerts.</a:t>
             </a:r>
           </a:p>
         </p:txBody>
@@ -5118,7 +5527,7 @@
               </a:defRPr>
             </a:pPr>
             <a:r>
-              <a:t>5. Project Modules &amp; proposed work</a:t>
+              <a:t>1.3 INTRODUCTION (PART 1)</a:t>
             </a:r>
           </a:p>
         </p:txBody>
@@ -5157,7 +5566,7 @@
               </a:defRPr>
             </a:pPr>
             <a:r>
-              <a:t>•  Geocoding Search Module: Converts name query strings to spatial coordinates.</a:t>
+              <a:t>•  Managing exposure to air pollutants (PM2.5, PM10, CO, NO2) is critical for patients with respiratory diseases.</a:t>
             </a:r>
           </a:p>
           <a:p>
@@ -5173,7 +5582,7 @@
               </a:defRPr>
             </a:pPr>
             <a:r>
-              <a:t>•  Atmospheric Blending Module: Blends live air chemistry forecasts and physical weather metrics.</a:t>
+              <a:t>•  Standard weather channels lack immediate health recommendations indicating outdoor activity safety.</a:t>
             </a:r>
           </a:p>
           <a:p>
@@ -5189,23 +5598,7 @@
               </a:defRPr>
             </a:pPr>
             <a:r>
-              <a:t>•  Diagnostics Module: Executes rule-based checks on pollution ratios and dispersion constraints.</a:t>
-            </a:r>
-          </a:p>
-          <a:p>
-            <a:pPr>
-              <a:spcAft>
-                <a:spcPts val="1600"/>
-              </a:spcAft>
-              <a:defRPr sz="2000">
-                <a:solidFill>
-                  <a:srgbClr val="111827"/>
-                </a:solidFill>
-                <a:latin typeface="Inter"/>
-              </a:defRPr>
-            </a:pPr>
-            <a:r>
-              <a:t>•  Relational Persistence Module: Controls SQLite3 records and syncs favorites dynamically.</a:t>
+              <a:t>•  This gap motivates the present project: an interactive atmospheric diagnostic dashboard.</a:t>
             </a:r>
           </a:p>
         </p:txBody>
@@ -5267,7 +5660,7 @@
               </a:defRPr>
             </a:pPr>
             <a:r>
-              <a:t>6. API Blending Logic</a:t>
+              <a:t>1.3 INTRODUCTION (PART 2)</a:t>
             </a:r>
           </a:p>
         </p:txBody>
@@ -5306,7 +5699,7 @@
               </a:defRPr>
             </a:pPr>
             <a:r>
-              <a:t>•  Orchestrates multiple HTTP request threads inside Flask to Open-Meteo and WAQI endpoints.</a:t>
+              <a:t>•  AeroQuest connects a Flask-based PYTHON backend to open-source geocoding and weather APIs.</a:t>
             </a:r>
           </a:p>
           <a:p>
@@ -5322,7 +5715,7 @@
               </a:defRPr>
             </a:pPr>
             <a:r>
-              <a:t>•  Open-Meteo forecast API yields PM2.5, PM10, CO, NO2, SO2, O3, Dust, and UV index forecasts.</a:t>
+              <a:t>•  Allows users to view local conditions on a custom dashboard, save preferred locations, and compare cities.</a:t>
             </a:r>
           </a:p>
           <a:p>
@@ -5338,23 +5731,7 @@
               </a:defRPr>
             </a:pPr>
             <a:r>
-              <a:t>•  WAQI feed queries geo-coordinates to fetch localized real-time ground-station sensors.</a:t>
-            </a:r>
-          </a:p>
-          <a:p>
-            <a:pPr>
-              <a:spcAft>
-                <a:spcPts val="1600"/>
-              </a:spcAft>
-              <a:defRPr sz="2000">
-                <a:solidFill>
-                  <a:srgbClr val="111827"/>
-                </a:solidFill>
-                <a:latin typeface="Inter"/>
-              </a:defRPr>
-            </a:pPr>
-            <a:r>
-              <a:t>•  API payloads are merged in real-time, scaled, and returned as a unified JSON response.</a:t>
+              <a:t>•  Bridges the gap between raw data indexes and daily personal wellness decisions.</a:t>
             </a:r>
           </a:p>
         </p:txBody>
@@ -5393,8 +5770,8 @@
         </p:nvSpPr>
         <p:spPr>
           <a:xfrm>
-            <a:off x="914400" y="731520"/>
-            <a:ext cx="10360152" cy="914400"/>
+            <a:off x="914400" y="2011680"/>
+            <a:ext cx="10360152" cy="2743200"/>
           </a:xfrm>
           <a:prstGeom prst="rect">
             <a:avLst/>
@@ -5402,108 +5779,37 @@
           <a:noFill/>
         </p:spPr>
         <p:txBody>
-          <a:bodyPr wrap="none">
-            <a:spAutoFit/>
-          </a:bodyPr>
-          <a:lstStyle/>
-          <a:p>
-            <a:pPr>
-              <a:defRPr sz="3600" b="1">
-                <a:solidFill>
-                  <a:srgbClr val="1A56DB"/>
-                </a:solidFill>
-                <a:latin typeface="Outfit"/>
-              </a:defRPr>
-            </a:pPr>
-            <a:r>
-              <a:t>7. WAQI Redirect Fallback Check</a:t>
-            </a:r>
-          </a:p>
-        </p:txBody>
-      </p:sp>
-      <p:sp>
-        <p:nvSpPr>
-          <p:cNvPr id="3" name="TextBox 2"/>
-          <p:cNvSpPr txBox="1"/>
-          <p:nvPr/>
-        </p:nvSpPr>
-        <p:spPr>
-          <a:xfrm>
-            <a:off x="914400" y="1828800"/>
-            <a:ext cx="10360152" cy="4114800"/>
-          </a:xfrm>
-          <a:prstGeom prst="rect">
-            <a:avLst/>
-          </a:prstGeom>
-          <a:noFill/>
-        </p:spPr>
-        <p:txBody>
           <a:bodyPr wrap="square">
             <a:spAutoFit/>
           </a:bodyPr>
           <a:lstStyle/>
           <a:p>
-            <a:pPr>
-              <a:spcAft>
-                <a:spcPts val="1600"/>
-              </a:spcAft>
-              <a:defRPr sz="2000">
-                <a:solidFill>
-                  <a:srgbClr val="111827"/>
-                </a:solidFill>
-                <a:latin typeface="Inter"/>
-              </a:defRPr>
-            </a:pPr>
-            <a:r>
-              <a:t>•  The Issue: WAQI geolocated requests without custom tokens redirect to Shanghai default.</a:t>
-            </a:r>
-          </a:p>
-          <a:p>
-            <a:pPr>
-              <a:spcAft>
-                <a:spcPts val="1600"/>
-              </a:spcAft>
-              <a:defRPr sz="2000">
-                <a:solidFill>
-                  <a:srgbClr val="111827"/>
-                </a:solidFill>
-                <a:latin typeface="Inter"/>
-              </a:defRPr>
-            </a:pPr>
-            <a:r>
-              <a:t>•  Coordinates Verification: Server calculates distance between requested coordinates and station coordinates.</a:t>
-            </a:r>
-          </a:p>
-          <a:p>
-            <a:pPr>
-              <a:spcAft>
-                <a:spcPts val="1600"/>
-              </a:spcAft>
-              <a:defRPr sz="2000">
-                <a:solidFill>
-                  <a:srgbClr val="111827"/>
-                </a:solidFill>
-                <a:latin typeface="Inter"/>
-              </a:defRPr>
-            </a:pPr>
-            <a:r>
-              <a:t>•  Threshold rule: If distance &gt; 2.0 degrees (~220 km), a redirect is flagged.</a:t>
-            </a:r>
-          </a:p>
-          <a:p>
-            <a:pPr>
-              <a:spcAft>
-                <a:spcPts val="1600"/>
-              </a:spcAft>
-              <a:defRPr sz="2000">
-                <a:solidFill>
-                  <a:srgbClr val="111827"/>
-                </a:solidFill>
-                <a:latin typeface="Inter"/>
-              </a:defRPr>
-            </a:pPr>
-            <a:r>
-              <a:t>•  Integrity Fallback: Fake station data is discarded, falling back to local Open-Meteo models.</a:t>
+            <a:pPr algn="ctr">
+              <a:defRPr sz="4400" b="1">
+                <a:solidFill>
+                  <a:srgbClr val="1A56DB"/>
+                </a:solidFill>
+                <a:latin typeface="Outfit"/>
+              </a:defRPr>
+            </a:pPr>
+            <a:r>
+              <a:t>CHAPTER 2</a:t>
+            </a:r>
+          </a:p>
+          <a:p>
+            <a:pPr algn="ctr">
+              <a:spcBef>
+                <a:spcPts val="1500"/>
+              </a:spcBef>
+              <a:defRPr sz="2800" b="1">
+                <a:solidFill>
+                  <a:srgbClr val="111827"/>
+                </a:solidFill>
+                <a:latin typeface="Outfit"/>
+              </a:defRPr>
+            </a:pPr>
+            <a:r>
+              <a:t>ALGORITHM / FLOWCHART &amp; CODE WITH COMMENTS</a:t>
             </a:r>
           </a:p>
         </p:txBody>
@@ -5565,7 +5871,7 @@
               </a:defRPr>
             </a:pPr>
             <a:r>
-              <a:t>8. SQLite Database Model</a:t>
+              <a:t>2.1 PROPOSED WORK &amp; ARCHITECTURE</a:t>
             </a:r>
           </a:p>
         </p:txBody>
@@ -5604,7 +5910,7 @@
               </a:defRPr>
             </a:pPr>
             <a:r>
-              <a:t>•  favorites table: Stores bookmarked locations (city, country, region, coordinates).</a:t>
+              <a:t>•  Centralized Controller: Flask server maps queries and requests atmospheric data feeds.</a:t>
             </a:r>
           </a:p>
           <a:p>
@@ -5620,7 +5926,7 @@
               </a:defRPr>
             </a:pPr>
             <a:r>
-              <a:t>•  Unique constraint on coordinates prevents redundant bookmark records.</a:t>
+              <a:t>•  Client Layer: JavaScript client requests geocoding coordinates and renders interactive maps.</a:t>
             </a:r>
           </a:p>
           <a:p>
@@ -5636,7 +5942,7 @@
               </a:defRPr>
             </a:pPr>
             <a:r>
-              <a:t>•  search_history table: Caches city search queries for quick reloading.</a:t>
+              <a:t>•  Database Caching Module: SQLite database logs recent searches and manages favorites.</a:t>
             </a:r>
           </a:p>
           <a:p>
@@ -5652,7 +5958,7 @@
               </a:defRPr>
             </a:pPr>
             <a:r>
-              <a:t>•  Pruning Algorithm: Automatically deletes older records, keeping only the 10 most recent.</a:t>
+              <a:t>•  APIs Layer: Geocoding, Open-Meteo forecasts, and WAQI ground-stations merged dynamically.</a:t>
             </a:r>
           </a:p>
         </p:txBody>

</xml_diff>